<commit_message>
Session 01 rebuilt on popular libraries: LangChain for documents, splitting, embeddings, the vector store, prompts, tools, and structured output; LangGraph through create_agent for the agent loop with a recursion limit; FastMCP for the indicator server and client, with a live listing of the Data360 MCP server's tools; pcn-core for number verification; the shared module reduced to the data, a recorded-output chat model, and helpers; notebooks re-executed with no errors
</commit_message>
<xml_diff>
--- a/training/session-01-building-ai-applications/slides/deck.pptx
+++ b/training/session-01-building-ai-applications/slides/deck.pptx
@@ -4358,7 +4358,7 @@
                   <a:srgbClr val="1F2A37"/>
                 </a:solidFill>
               </a:rPr>
-              <a:t>The Model Context Protocol is a standard for exposing tools like get_indicator to any AI client. The program's Data360 MCP server exposes search, metadata, and data tools over the World Bank data platform; a desktop assistant, the Data AI Chatbot, or a notebook call the same tools.</a:t>
+              <a:t>The Model Context Protocol is a standard for exposing tools like get_indicator to any AI client. Notebook 04 serves the tool with FastMCP in a dozen lines and calls it back through the FastMCP client. The program's Data360 MCP server exposes search, metadata, and data tools over the World Bank data platform; a desktop assistant, the Data AI Chatbot, or a notebook call the same tools.</a:t>
             </a:r>
             <a:endParaRPr lang="en-US" sz="1300" dirty="0"/>
           </a:p>
@@ -4709,7 +4709,7 @@
                   <a:srgbClr val="5B6B7C"/>
                 </a:solidFill>
               </a:rPr>
-              <a:t>The notebooks keep tools as local functions so that they run offline; the shape of a tool is the same.</a:t>
+              <a:t>The notebook lists the Data360 server's sixteen tools and runs one search live, with a guard for offline sessions.</a:t>
             </a:r>
             <a:endParaRPr lang="en-US" sz="1250" dirty="0"/>
           </a:p>
@@ -7095,7 +7095,7 @@
                 <a:ea typeface="Courier New" pitchFamily="34" charset="-122"/>
                 <a:cs typeface="Courier New" pitchFamily="34" charset="-120"/>
               </a:rPr>
-              <a:t>passages = search(question)</a:t>
+              <a:t>passages = search_documents.invoke({"query": question})</a:t>
             </a:r>
             <a:endParaRPr lang="en-US" sz="1100" dirty="0"/>
           </a:p>
@@ -7112,7 +7112,7 @@
                 <a:ea typeface="Courier New" pitchFamily="34" charset="-122"/>
                 <a:cs typeface="Courier New" pitchFamily="34" charset="-120"/>
               </a:rPr>
-              <a:t>series   = [get_indicator(i, c) for i, c in PAIRS]</a:t>
+              <a:t>series   = [indicator_lookup(i, c) for i, c in PAIRS]</a:t>
             </a:r>
             <a:endParaRPr lang="en-US" sz="1100" dirty="0"/>
           </a:p>
@@ -7129,7 +7129,7 @@
                 <a:ea typeface="Courier New" pitchFamily="34" charset="-122"/>
                 <a:cs typeface="Courier New" pitchFamily="34" charset="-120"/>
               </a:rPr>
-              <a:t>answer   = model(instructions, passages, series)</a:t>
+              <a:t>answer   = (prompt | model).invoke({...})</a:t>
             </a:r>
             <a:endParaRPr lang="en-US" sz="1100" dirty="0"/>
           </a:p>
@@ -7269,7 +7269,7 @@
                 <a:ea typeface="Courier New" pitchFamily="34" charset="-122"/>
                 <a:cs typeface="Courier New" pitchFamily="34" charset="-120"/>
               </a:rPr>
-              <a:t>for step in range(max_steps):</a:t>
+              <a:t>agent = create_agent(model, tools, system_prompt=...)</a:t>
             </a:r>
             <a:endParaRPr lang="en-US" sz="1100" dirty="0"/>
           </a:p>
@@ -7286,7 +7286,7 @@
                 <a:ea typeface="Courier New" pitchFamily="34" charset="-122"/>
                 <a:cs typeface="Courier New" pitchFamily="34" charset="-120"/>
               </a:rPr>
-              <a:t>    reply = model(messages, tools)</a:t>
+              <a:t>result = agent.invoke({"messages": [question]},</a:t>
             </a:r>
             <a:endParaRPr lang="en-US" sz="1100" dirty="0"/>
           </a:p>
@@ -7303,7 +7303,7 @@
                 <a:ea typeface="Courier New" pitchFamily="34" charset="-122"/>
                 <a:cs typeface="Courier New" pitchFamily="34" charset="-120"/>
               </a:rPr>
-              <a:t>    if not reply.tool_calls: return reply</a:t>
+              <a:t>                      config={"recursion_limit": 10})</a:t>
             </a:r>
             <a:endParaRPr lang="en-US" sz="1100" dirty="0"/>
           </a:p>
@@ -7320,7 +7320,7 @@
                 <a:ea typeface="Courier New" pitchFamily="34" charset="-122"/>
                 <a:cs typeface="Courier New" pitchFamily="34" charset="-120"/>
               </a:rPr>
-              <a:t>    run the calls; append results; record the trace</a:t>
+              <a:t># LangGraph runs the loop; the messages are the trace</a:t>
             </a:r>
             <a:endParaRPr lang="en-US" sz="1100" dirty="0"/>
           </a:p>
@@ -7356,7 +7356,7 @@
                   <a:srgbClr val="1F2A37"/>
                 </a:solidFill>
               </a:rPr>
-              <a:t>Three controls for the loop: a step limit, a trace of every call and result, and tools that return errors as data so that the model can retry. Demonstration: notebook 05, an out-of-scope question, a failed call, and the step limit.</a:t>
+              <a:t>Three controls for the loop: a recursion limit, the message trace of every call and result, and tools that return errors as data so that the model can retry. Demonstration: notebook 05, an out-of-scope question, a failed call, and the limit.</a:t>
             </a:r>
             <a:endParaRPr lang="en-US" sz="1300" dirty="0"/>
           </a:p>
@@ -9363,7 +9363,7 @@
                   <a:srgbClr val="5B6B7C"/>
                 </a:solidFill>
               </a:rPr>
-              <a:t>This is the Proof-Carrying Numbers protocol used in the program's chatbot, reduced to one function in the notebook.</a:t>
+              <a:t>This is the Proof-Carrying Numbers protocol used in the program's chatbot; the notebook compares with the same pcn-core code.</a:t>
             </a:r>
             <a:endParaRPr lang="en-US" sz="1250" dirty="0"/>
           </a:p>
@@ -13756,7 +13756,7 @@
                   <a:srgbClr val="1F2A37"/>
                 </a:solidFill>
               </a:rPr>
-              <a:t>Rerun the six notebooks with a question and documents of their own</a:t>
+              <a:t>Rerun the six notebooks, built on LangChain, LangGraph, FastMCP, and pcn-core, with a question and documents of their own</a:t>
             </a:r>
             <a:endParaRPr lang="en-US" sz="1400" dirty="0"/>
           </a:p>
@@ -13967,7 +13967,7 @@
                   <a:srgbClr val="1F2A37"/>
                 </a:solidFill>
               </a:rPr>
-              <a:t>Everything runs without an API key; model outputs are then recorded and labelled</a:t>
+              <a:t>Everything runs without an API key; model outputs are then recorded and labelled. Stack: LangChain, LangGraph, FastMCP, Pydantic, pcn-core</a:t>
             </a:r>
             <a:endParaRPr lang="en-US" sz="1400" dirty="0"/>
           </a:p>
@@ -14169,7 +14169,7 @@
                   <a:srgbClr val="1F2A37"/>
                 </a:solidFill>
               </a:rPr>
-              <a:t>The shared module, workshop.py, about 500 lines</a:t>
+              <a:t>The shared module and the FastMCP server, about 450 lines on top of the libraries</a:t>
             </a:r>
             <a:endParaRPr lang="en-US" sz="1300" dirty="0"/>
           </a:p>
@@ -19651,7 +19651,7 @@
                   <a:srgbClr val="1F2A37"/>
                 </a:solidFill>
               </a:rPr>
-              <a:t>A vector per chunk; similar meaning, nearby vectors. A small local model in Colab, TF-IDF as the fallback. The index is only as good as the text and metadata it was built from.</a:t>
+              <a:t>A vector per chunk; similar meaning, nearby vectors. A small sentence-transformer model through LangChain, held in a vector store. The index is only as good as the text and metadata it was built from.</a:t>
             </a:r>
             <a:endParaRPr lang="en-US" sz="1250" dirty="0"/>
           </a:p>

</xml_diff>